<commit_message>
Deploying to gh-pages from @ tamanh-oxford/capacity-development@ee72ac222217ab0f62ee6f6d77fb9647e3944ee1 🚀
</commit_message>
<xml_diff>
--- a/data-frameworks/12-financing-data.pptx
+++ b/data-frameworks/12-financing-data.pptx
@@ -22,6 +22,8 @@
     <p:sldId id="270" r:id="rId16"/>
     <p:sldId id="271" r:id="rId17"/>
     <p:sldId id="272" r:id="rId18"/>
+    <p:sldId id="273" r:id="rId19"/>
+    <p:sldId id="274" r:id="rId20"/>
   </p:sldIdLst>
   <p:sldSz cx="9144000" cy="5143500" type="screen16x9"/>
   <p:notesSz cx="6858000" cy="9144000"/>
@@ -3607,36 +3609,6 @@
           </a:p>
         </p:txBody>
       </p:sp>
-      <p:sp>
-        <p:nvSpPr>
-          <p:cNvPr id="3" name="Content Placeholder 2"/>
-          <p:cNvSpPr>
-            <a:spLocks noGrp="1"/>
-          </p:cNvSpPr>
-          <p:nvPr>
-            <p:ph idx="1" sz="half"/>
-          </p:nvPr>
-        </p:nvSpPr>
-        <p:spPr/>
-        <p:txBody>
-          <a:bodyPr/>
-          <a:lstStyle/>
-          <a:p>
-            <a:pPr lvl="0"/>
-            <a:r>
-              <a:rPr/>
-              <a:t>About 530,000 days of managers’ time wasted by poor quality and undocumented data (equivalent to some $250 million in wages annually)</a:t>
-            </a:r>
-          </a:p>
-          <a:p>
-            <a:pPr lvl="0"/>
-            <a:r>
-              <a:rPr/>
-              <a:t>By just simply documenting your metadata can reduce data-related expenses by up to 97%</a:t>
-            </a:r>
-          </a:p>
-        </p:txBody>
-      </p:sp>
       <p:pic>
         <p:nvPicPr>
           <p:cNvPr descr="../images/fin_costs_02.png" id="0" name="Picture 1"/>
@@ -3653,8 +3625,8 @@
         </p:blipFill>
         <p:spPr bwMode="auto">
           <a:xfrm>
-            <a:off x="4648200" y="2082800"/>
-            <a:ext cx="4038600" cy="1600200"/>
+            <a:off x="457200" y="1257300"/>
+            <a:ext cx="8229600" cy="3263900"/>
           </a:xfrm>
           <a:prstGeom prst="rect">
             <a:avLst/>
@@ -3691,6 +3663,58 @@
       </p:grpSpPr>
       <p:sp>
         <p:nvSpPr>
+          <p:cNvPr id="3" name="Content Placeholder 2"/>
+          <p:cNvSpPr>
+            <a:spLocks noGrp="1"/>
+          </p:cNvSpPr>
+          <p:nvPr>
+            <p:ph idx="1"/>
+          </p:nvPr>
+        </p:nvSpPr>
+        <p:spPr/>
+        <p:txBody>
+          <a:bodyPr/>
+          <a:lstStyle/>
+          <a:p>
+            <a:pPr lvl="0"/>
+            <a:r>
+              <a:rPr/>
+              <a:t>About 530,000 days of managers’ time wasted by poor quality and undocumented data (equivalent to some $250 million in wages annually)</a:t>
+            </a:r>
+          </a:p>
+          <a:p>
+            <a:pPr lvl="0"/>
+            <a:r>
+              <a:rPr/>
+              <a:t>By just simply documenting your metadata can reduce data-related expenses by up to 97%</a:t>
+            </a:r>
+          </a:p>
+        </p:txBody>
+      </p:sp>
+    </p:spTree>
+  </p:cSld>
+</p:sld>
+</file>
+
+<file path=ppt/slides/slide17.xml><?xml version="1.0" encoding="utf-8"?>
+<p:sld xmlns:a="http://schemas.openxmlformats.org/drawingml/2006/main" xmlns:r="http://schemas.openxmlformats.org/officeDocument/2006/relationships" xmlns:p="http://schemas.openxmlformats.org/presentationml/2006/main">
+  <p:cSld>
+    <p:spTree>
+      <p:nvGrpSpPr>
+        <p:cNvPr id="1" name=""/>
+        <p:cNvGrpSpPr/>
+        <p:nvPr/>
+      </p:nvGrpSpPr>
+      <p:grpSpPr>
+        <a:xfrm>
+          <a:off x="0" y="0"/>
+          <a:ext cx="0" cy="0"/>
+          <a:chOff x="0" y="0"/>
+          <a:chExt cx="0" cy="0"/>
+        </a:xfrm>
+      </p:grpSpPr>
+      <p:sp>
+        <p:nvSpPr>
           <p:cNvPr id="2" name="Title 1"/>
           <p:cNvSpPr>
             <a:spLocks noGrp="1"/>
@@ -3710,36 +3734,6 @@
             <a:r>
               <a:rPr/>
               <a:t>Reducing risk with data</a:t>
-            </a:r>
-          </a:p>
-        </p:txBody>
-      </p:sp>
-      <p:sp>
-        <p:nvSpPr>
-          <p:cNvPr id="3" name="Content Placeholder 2"/>
-          <p:cNvSpPr>
-            <a:spLocks noGrp="1"/>
-          </p:cNvSpPr>
-          <p:nvPr>
-            <p:ph idx="1" sz="half"/>
-          </p:nvPr>
-        </p:nvSpPr>
-        <p:spPr/>
-        <p:txBody>
-          <a:bodyPr/>
-          <a:lstStyle/>
-          <a:p>
-            <a:pPr lvl="0"/>
-            <a:r>
-              <a:rPr/>
-              <a:t>Regulatory risk (GDPR fines, for example)</a:t>
-            </a:r>
-          </a:p>
-          <a:p>
-            <a:pPr lvl="0"/>
-            <a:r>
-              <a:rPr/>
-              <a:t>Cybersecurity risk (both costs of the response and erosion of customer trust)</a:t>
             </a:r>
           </a:p>
         </p:txBody>
@@ -3760,8 +3754,8 @@
         </p:blipFill>
         <p:spPr bwMode="auto">
           <a:xfrm>
-            <a:off x="4648200" y="2019300"/>
-            <a:ext cx="4038600" cy="1752600"/>
+            <a:off x="647700" y="1193800"/>
+            <a:ext cx="7835900" cy="3390900"/>
           </a:xfrm>
           <a:prstGeom prst="rect">
             <a:avLst/>
@@ -3779,7 +3773,59 @@
 </p:sld>
 </file>
 
-<file path=ppt/slides/slide17.xml><?xml version="1.0" encoding="utf-8"?>
+<file path=ppt/slides/slide18.xml><?xml version="1.0" encoding="utf-8"?>
+<p:sld xmlns:a="http://schemas.openxmlformats.org/drawingml/2006/main" xmlns:r="http://schemas.openxmlformats.org/officeDocument/2006/relationships" xmlns:p="http://schemas.openxmlformats.org/presentationml/2006/main">
+  <p:cSld>
+    <p:spTree>
+      <p:nvGrpSpPr>
+        <p:cNvPr id="1" name=""/>
+        <p:cNvGrpSpPr/>
+        <p:nvPr/>
+      </p:nvGrpSpPr>
+      <p:grpSpPr>
+        <a:xfrm>
+          <a:off x="0" y="0"/>
+          <a:ext cx="0" cy="0"/>
+          <a:chOff x="0" y="0"/>
+          <a:chExt cx="0" cy="0"/>
+        </a:xfrm>
+      </p:grpSpPr>
+      <p:sp>
+        <p:nvSpPr>
+          <p:cNvPr id="3" name="Content Placeholder 2"/>
+          <p:cNvSpPr>
+            <a:spLocks noGrp="1"/>
+          </p:cNvSpPr>
+          <p:nvPr>
+            <p:ph idx="1"/>
+          </p:nvPr>
+        </p:nvSpPr>
+        <p:spPr/>
+        <p:txBody>
+          <a:bodyPr/>
+          <a:lstStyle/>
+          <a:p>
+            <a:pPr lvl="0"/>
+            <a:r>
+              <a:rPr/>
+              <a:t>Regulatory risk (GDPR fines, for example)</a:t>
+            </a:r>
+          </a:p>
+          <a:p>
+            <a:pPr lvl="0"/>
+            <a:r>
+              <a:rPr/>
+              <a:t>Cybersecurity risk (both costs of the response and erosion of customer trust)</a:t>
+            </a:r>
+          </a:p>
+        </p:txBody>
+      </p:sp>
+    </p:spTree>
+  </p:cSld>
+</p:sld>
+</file>
+
+<file path=ppt/slides/slide19.xml><?xml version="1.0" encoding="utf-8"?>
 <p:sld xmlns:a="http://schemas.openxmlformats.org/drawingml/2006/main" xmlns:r="http://schemas.openxmlformats.org/officeDocument/2006/relationships" xmlns:p="http://schemas.openxmlformats.org/presentationml/2006/main">
   <p:cSld>
     <p:spTree>

</xml_diff>